<commit_message>
feat(ui): explicit bulk 'treat as all-day' for events with no stated duration
Only events whose sole gap is a missing duration are eligible; ambiguous, conflicting, untitled and not-in-grid events are excluded. Requires a confirmation dialog, records an edit-history entry per event. 8 unit tests + e2e. Docs and deck updated with the real-calendar result.

Co-Authored-By: Claude Sonnet 5.5 <noreply@anthropic.com>
</commit_message>
<xml_diff>
--- a/presentation/SchoolSync-AI.pptx
+++ b/presentation/SchoolSync-AI.pptx
@@ -6379,7 +6379,7 @@
               </a:defRPr>
             </a:pPr>
             <a:r>
-              <a:t>2 synthetic PDFs, 13 labelled events</a:t>
+              <a:t>3 synthetic PDFs, 26 labelled events</a:t>
             </a:r>
           </a:p>
         </p:txBody>
@@ -6403,9 +6403,10 @@
                 <a:tableStyleId>{5C22544A-7EE6-4342-B048-85BDC9FD1C3A}</a:tableStyleId>
               </a:tblPr>
               <a:tblGrid>
-                <a:gridCol w="2255520"/>
-                <a:gridCol w="2255520"/>
-                <a:gridCol w="2255520"/>
+                <a:gridCol w="1691640"/>
+                <a:gridCol w="1691640"/>
+                <a:gridCol w="1691640"/>
+                <a:gridCol w="1691640"/>
               </a:tblGrid>
               <a:tr h="411480">
                 <a:tc>
@@ -6453,6 +6454,21 @@
                   </a:txBody>
                   <a:tcPr/>
                 </a:tc>
+                <a:tc>
+                  <a:txBody>
+                    <a:bodyPr/>
+                    <a:lstStyle/>
+                    <a:p>
+                      <a:pPr>
+                        <a:defRPr sz="1300"/>
+                      </a:pPr>
+                      <a:r>
+                        <a:t>cedar_hill_2025_26</a:t>
+                      </a:r>
+                    </a:p>
+                  </a:txBody>
+                  <a:tcPr/>
+                </a:tc>
               </a:tr>
               <a:tr h="411480">
                 <a:tc>
@@ -6465,6 +6481,21 @@
                       </a:pPr>
                       <a:r>
                         <a:t>Precision</a:t>
+                      </a:r>
+                    </a:p>
+                  </a:txBody>
+                  <a:tcPr/>
+                </a:tc>
+                <a:tc>
+                  <a:txBody>
+                    <a:bodyPr/>
+                    <a:lstStyle/>
+                    <a:p>
+                      <a:pPr>
+                        <a:defRPr sz="1300"/>
+                      </a:pPr>
+                      <a:r>
+                        <a:t>1.00</a:t>
                       </a:r>
                     </a:p>
                   </a:txBody>
@@ -6547,6 +6578,21 @@
                   </a:txBody>
                   <a:tcPr/>
                 </a:tc>
+                <a:tc>
+                  <a:txBody>
+                    <a:bodyPr/>
+                    <a:lstStyle/>
+                    <a:p>
+                      <a:pPr>
+                        <a:defRPr sz="1300"/>
+                      </a:pPr>
+                      <a:r>
+                        <a:t>1.00</a:t>
+                      </a:r>
+                    </a:p>
+                  </a:txBody>
+                  <a:tcPr/>
+                </a:tc>
               </a:tr>
               <a:tr h="411480">
                 <a:tc>
@@ -6559,6 +6605,21 @@
                       </a:pPr>
                       <a:r>
                         <a:t>Category accuracy</a:t>
+                      </a:r>
+                    </a:p>
+                  </a:txBody>
+                  <a:tcPr/>
+                </a:tc>
+                <a:tc>
+                  <a:txBody>
+                    <a:bodyPr/>
+                    <a:lstStyle/>
+                    <a:p>
+                      <a:pPr>
+                        <a:defRPr sz="1300"/>
+                      </a:pPr>
+                      <a:r>
+                        <a:t>1.00</a:t>
                       </a:r>
                     </a:p>
                   </a:txBody>
@@ -6641,6 +6702,21 @@
                   </a:txBody>
                   <a:tcPr/>
                 </a:tc>
+                <a:tc>
+                  <a:txBody>
+                    <a:bodyPr/>
+                    <a:lstStyle/>
+                    <a:p>
+                      <a:pPr>
+                        <a:defRPr sz="1300"/>
+                      </a:pPr>
+                      <a:r>
+                        <a:t>1.00</a:t>
+                      </a:r>
+                    </a:p>
+                  </a:txBody>
+                  <a:tcPr/>
+                </a:tc>
               </a:tr>
               <a:tr h="411480">
                 <a:tc>
@@ -6653,6 +6729,21 @@
                       </a:pPr>
                       <a:r>
                         <a:t>Status accuracy</a:t>
+                      </a:r>
+                    </a:p>
+                  </a:txBody>
+                  <a:tcPr/>
+                </a:tc>
+                <a:tc>
+                  <a:txBody>
+                    <a:bodyPr/>
+                    <a:lstStyle/>
+                    <a:p>
+                      <a:pPr>
+                        <a:defRPr sz="1300"/>
+                      </a:pPr>
+                      <a:r>
+                        <a:t>1.00</a:t>
                       </a:r>
                     </a:p>
                   </a:txBody>
@@ -6735,6 +6826,21 @@
                   </a:txBody>
                   <a:tcPr/>
                 </a:tc>
+                <a:tc>
+                  <a:txBody>
+                    <a:bodyPr/>
+                    <a:lstStyle/>
+                    <a:p>
+                      <a:pPr>
+                        <a:defRPr sz="1300"/>
+                      </a:pPr>
+                      <a:r>
+                        <a:t>1.00</a:t>
+                      </a:r>
+                    </a:p>
+                  </a:txBody>
+                  <a:tcPr/>
+                </a:tc>
               </a:tr>
               <a:tr h="411480">
                 <a:tc>
@@ -6777,6 +6883,21 @@
                       </a:pPr>
                       <a:r>
                         <a:t>0.20</a:t>
+                      </a:r>
+                    </a:p>
+                  </a:txBody>
+                  <a:tcPr/>
+                </a:tc>
+                <a:tc>
+                  <a:txBody>
+                    <a:bodyPr/>
+                    <a:lstStyle/>
+                    <a:p>
+                      <a:pPr>
+                        <a:defRPr sz="1300"/>
+                      </a:pPr>
+                      <a:r>
+                        <a:t>0.85</a:t>
                       </a:r>
                     </a:p>
                   </a:txBody>

</xml_diff>